<commit_message>
Final changes to slides
Removed unnecessary details and updated speaker notes
</commit_message>
<xml_diff>
--- a/SongNet_Slides.pptx
+++ b/SongNet_Slides.pptx
@@ -630,7 +630,13 @@
           <a:p>
             <a:r>
               <a:rPr lang="en-US" dirty="0"/>
-              <a:t>SongNet re-implementation (Zhang, Zhang, Chen, Stanford CS229) with two head variants, compared with five classical baselines on FMA-Small.</a:t>
+              <a:t>Our project focuses on classifying music into eight genres while also examining how the model's genre predictions evolve over time within an audio clip.</a:t>
+            </a:r>
+          </a:p>
+          <a:p>
+            <a:r>
+              <a:rPr lang="en-US" dirty="0"/>
+              <a:t>The project has two main goals: predict the overall genre of a song and visualize the genre probabilities at different moments of the song.</a:t>
             </a:r>
           </a:p>
         </p:txBody>
@@ -717,7 +723,19 @@
           <a:p>
             <a:r>
               <a:rPr lang="en-US" dirty="0"/>
-              <a:t>Be clear in the viva: we implemented time-resolved prediction and visualisation. We did not benchmark live streaming latency.</a:t>
+              <a:t>The task is to classify a 30-second music clip into one of eight genres.</a:t>
+            </a:r>
+          </a:p>
+          <a:p>
+            <a:r>
+              <a:rPr lang="en-US" dirty="0"/>
+              <a:t>A conventional approach often represents an entire track using a single feature vector. This can lose information about how the music changes over time.</a:t>
+            </a:r>
+          </a:p>
+          <a:p>
+            <a:r>
+              <a:rPr lang="en-US" dirty="0"/>
+              <a:t>Our approach uses a log-Mel spectrogram as input to a convolutional recurrent neural network. It produces genre probabilities at multiple time steps, which we visualize using curves and a heatmap.</a:t>
             </a:r>
           </a:p>
         </p:txBody>
@@ -804,7 +822,55 @@
           <a:p>
             <a:r>
               <a:rPr lang="en-US" dirty="0"/>
-              <a:t>Original dataset has 8,000 tracks (1,000 per genre). Three MP3s were corrupt and skipped in preprocessing, so 7,997 were used: 5,597 train, 1,600 validation, 800 test.</a:t>
+              <a:t>"We used FMA-Small, which contains 8,000 30-second music clips distributed across eight genres.</a:t>
+            </a:r>
+          </a:p>
+          <a:p>
+            <a:r>
+              <a:rPr lang="en-US" dirty="0"/>
+              <a:t>During preprocessing, three corrupt MP3 files were skipped, leaving 7,997 usable tracks.</a:t>
+            </a:r>
+          </a:p>
+          <a:p>
+            <a:r>
+              <a:rPr lang="en-US" dirty="0"/>
+              <a:t>We used a stratified 70-20-10 split. This gave us 5,597 tracks for training, 1,600 for validation and 800 for testing. The test set contains 100 tracks from each genre.</a:t>
+            </a:r>
+          </a:p>
+          <a:p>
+            <a:r>
+              <a:rPr lang="en-US" dirty="0"/>
+              <a:t>We converted the audio into log-Mel spectrograms with 128 Mel frequency bins. Each track has an input representation of 128 by 1292."</a:t>
+            </a:r>
+          </a:p>
+          <a:p>
+            <a:r>
+              <a:rPr lang="en-US" b="1" dirty="0"/>
+              <a:t>What does 128 × 1292 mean?</a:t>
+            </a:r>
+          </a:p>
+          <a:p>
+            <a:r>
+              <a:rPr lang="en-US" dirty="0"/>
+              <a:t>This is worth memorizing.</a:t>
+            </a:r>
+          </a:p>
+          <a:p>
+            <a:r>
+              <a:rPr lang="en-US" dirty="0"/>
+              <a:t>128: Mel frequency bins.</a:t>
+            </a:r>
+          </a:p>
+          <a:p>
+            <a:r>
+              <a:rPr lang="en-US" dirty="0"/>
+              <a:t>1292: Time frames.</a:t>
+            </a:r>
+          </a:p>
+          <a:p>
+            <a:r>
+              <a:rPr lang="en-US" dirty="0"/>
+              <a:t>A spectrogram shows how the energy across frequency bands changes over time.</a:t>
             </a:r>
           </a:p>
         </p:txBody>
@@ -891,33 +957,40 @@
           <a:p>
             <a:r>
               <a:rPr lang="en-US" dirty="0"/>
-              <a:t>Start from the left:</a:t>
-            </a:r>
+              <a:t>"Our architecture has one shared CNN backbone and two alternative classification heads.</a:t>
+            </a:r>
+          </a:p>
+          <a:p>
+            <a:endParaRPr lang="en-US" dirty="0"/>
           </a:p>
           <a:p>
             <a:r>
               <a:rPr lang="en-US" dirty="0"/>
-              <a:t>“The input to the model is our 128 by 1292 log-Mel spectrogram.”</a:t>
+              <a:t>First, the input spectrogram passes through three Conv1D blocks. These extract useful local acoustic patterns from the audio.</a:t>
             </a:r>
           </a:p>
           <a:p>
             <a:r>
               <a:rPr lang="en-US" dirty="0"/>
-              <a:t>Then:</a:t>
+              <a:t>The feature representation is then passed to one of two heads.</a:t>
             </a:r>
           </a:p>
           <a:p>
             <a:r>
               <a:rPr lang="en-US" dirty="0"/>
-              <a:t>“First, we pass it through three Conv1D blocks. These consist of convolution, batch normalization, </a:t>
-            </a:r>
-            <a:r>
-              <a:rPr lang="en-US" dirty="0" err="1"/>
-              <a:t>ReLU</a:t>
-            </a:r>
+              <a:t>The first is the Time-Distributed head. It applies a 1×1 convolution at each time step without a recurrent layer.</a:t>
+            </a:r>
+          </a:p>
+          <a:p>
             <a:r>
               <a:rPr lang="en-US" dirty="0"/>
-              <a:t> activation, max pooling and dropout.”</a:t>
+              <a:t>The second is the GRU head. It uses a unidirectional GRU with hidden size 128 to model the temporal relationships between the extracted features.</a:t>
+            </a:r>
+          </a:p>
+          <a:p>
+            <a:r>
+              <a:rPr lang="en-US" dirty="0"/>
+              <a:t>Both heads produce eight genre probabilities at each of 161 output time steps. We average the probabilities across time to obtain the final song-level prediction.“</a:t>
             </a:r>
           </a:p>
           <a:p>
@@ -925,87 +998,32 @@
           </a:p>
           <a:p>
             <a:r>
+              <a:rPr lang="en-US" b="1" dirty="0"/>
+              <a:t>The critical concept: What is a CRNN?</a:t>
+            </a:r>
+          </a:p>
+          <a:p>
+            <a:r>
               <a:rPr lang="en-US" dirty="0"/>
-              <a:t>Then explain the two branches.</a:t>
-            </a:r>
-          </a:p>
-          <a:p>
-            <a:r>
-              <a:rPr lang="en-US" b="1" dirty="0"/>
-              <a:t>Head A — Time-Distributed</a:t>
+              <a:t>CRNN = Convolutional Recurrent Neural Network.</a:t>
             </a:r>
           </a:p>
           <a:p>
             <a:r>
               <a:rPr lang="en-US" dirty="0"/>
-              <a:t>“The first head is the Time-Distributed head. It applies a 1x1 convolution at each time step to produce eight genre probabilities.”</a:t>
+              <a:t>Think of the two components like this:</a:t>
             </a:r>
           </a:p>
           <a:p>
             <a:r>
               <a:rPr lang="en-US" dirty="0"/>
-              <a:t>Then:</a:t>
+              <a:t>CNN: Learns local acoustic patterns from the spectrogram.</a:t>
             </a:r>
           </a:p>
           <a:p>
             <a:r>
               <a:rPr lang="en-US" dirty="0"/>
-              <a:t>“We have predictions at every timestep, and we average those probabilities across time to obtain the final song-level prediction.”</a:t>
-            </a:r>
-          </a:p>
-          <a:p>
-            <a:r>
-              <a:rPr lang="en-US" b="1" dirty="0"/>
-              <a:t>Head B — GRU</a:t>
-            </a:r>
-          </a:p>
-          <a:p>
-            <a:r>
-              <a:rPr lang="en-US" dirty="0"/>
-              <a:t>Point to the GRU:</a:t>
-            </a:r>
-          </a:p>
-          <a:p>
-            <a:r>
-              <a:rPr lang="en-US" dirty="0"/>
-              <a:t>“The second head adds a unidirectional GRU with hidden size 128. This gives us the CRNN architecture — convolution extracts local audio features and the GRU models their temporal relationships.”</a:t>
-            </a:r>
-          </a:p>
-          <a:p>
-            <a:r>
-              <a:rPr lang="en-US" b="1" dirty="0"/>
-              <a:t>The key sentence</a:t>
-            </a:r>
-          </a:p>
-          <a:p>
-            <a:r>
-              <a:rPr lang="en-US" dirty="0"/>
-              <a:t>Memorize this:</a:t>
-            </a:r>
-          </a:p>
-          <a:p>
-            <a:r>
-              <a:rPr lang="en-US" b="1" dirty="0"/>
-              <a:t>“CNN learns local acoustic patterns, while the GRU learns how those patterns evolve over time.”</a:t>
-            </a:r>
-            <a:endParaRPr lang="en-US" dirty="0"/>
-          </a:p>
-          <a:p>
-            <a:r>
-              <a:rPr lang="en-US" dirty="0"/>
-              <a:t>That's probably the cleanest way to explain your architecture.</a:t>
-            </a:r>
-          </a:p>
-          <a:p>
-            <a:r>
-              <a:rPr lang="en-US" b="1" dirty="0"/>
-              <a:t>If professor asks: "Why two heads?"</a:t>
-            </a:r>
-          </a:p>
-          <a:p>
-            <a:r>
-              <a:rPr lang="en-US" dirty="0"/>
-              <a:t>“The Time-Distributed head gives us a non-recurrent baseline, while the GRU head lets us measure whether explicitly modeling temporal dependencies improves performance.”</a:t>
+              <a:t>GRU: Uses the sequence of features to model how those patterns evolve over time.</a:t>
             </a:r>
           </a:p>
           <a:p>
@@ -1095,13 +1113,13 @@
           <a:p>
             <a:r>
               <a:rPr lang="en-US" dirty="0"/>
-              <a:t>“For training, we used CUDA acceleration with a batch size of 32 and trained for 20 epochs”</a:t>
+              <a:t>We trained the Time-Distributed model for 20 epochs, using a batch size of 32, dropout of 0.3 and CUDA acceleration.</a:t>
             </a:r>
           </a:p>
           <a:p>
             <a:r>
               <a:rPr lang="en-US" dirty="0"/>
-              <a:t>“We used Adam with an initial learning rate of 0.001 and weight decay of 0.0001. We also used </a:t>
+              <a:t>We used Adam as the optimizer, with an initial learning rate of 0.001 and weight decay of 0.0001. We also used </a:t>
             </a:r>
             <a:r>
               <a:rPr lang="en-US" dirty="0" err="1"/>
@@ -1109,25 +1127,19 @@
             </a:r>
             <a:r>
               <a:rPr lang="en-US" dirty="0"/>
-              <a:t> to reduce the learning rate when validation performance stopped improving.”</a:t>
+              <a:t> to reduce the learning rate when the monitored validation metric stopped improving.</a:t>
             </a:r>
           </a:p>
           <a:p>
             <a:r>
               <a:rPr lang="en-US" dirty="0"/>
-              <a:t>“During training, we randomly cropped 640 frames from the spectrogram, corresponding to approximately 14.9 seconds. During testing, we used the complete 1292-frame representation.”</a:t>
-            </a:r>
-          </a:p>
-          <a:p>
-            <a:r>
-              <a:rPr lang="en-US" b="1" dirty="0"/>
-              <a:t>Why crop during training?</a:t>
+              <a:t>During training, we randomly cropped 640 frames, corresponding to approximately 14.9 seconds, while testing used the full 1292-frame spectrogram.</a:t>
             </a:r>
           </a:p>
           <a:p>
             <a:r>
               <a:rPr lang="en-US" dirty="0"/>
-              <a:t>If asked:</a:t>
+              <a:t>The Time-Distributed run reached a best validation accuracy of 55.75%. We also trained the GRU variant with the same training script.</a:t>
             </a:r>
           </a:p>
           <a:p>
@@ -1220,20 +1232,34 @@
           <a:p>
             <a:r>
               <a:rPr lang="en-US" dirty="0"/>
-              <a:t>“Now coming to our results, the best-performing model was our GRU-based CRNN.”</a:t>
+              <a:t>Our final results are evaluated on the held-out test set of 800 tracks.</a:t>
             </a:r>
           </a:p>
           <a:p>
             <a:r>
               <a:rPr lang="en-US" dirty="0"/>
-              <a:t>“The strongest classical baseline was Logistic Regression at 56.12%.”</a:t>
-            </a:r>
-          </a:p>
-          <a:p>
-            <a:endParaRPr lang="en-US" dirty="0"/>
-          </a:p>
-          <a:p>
-            <a:endParaRPr lang="en-US" dirty="0"/>
+              <a:t>The GRU/CRNN achieved 59.75% test accuracy and a macro F1 score of 0.5897, making it the best-performing model in this experiment.</a:t>
+            </a:r>
+          </a:p>
+          <a:p>
+            <a:r>
+              <a:rPr lang="en-US" dirty="0"/>
+              <a:t>The strongest classical baseline was Logistic Regression at 56.12%. Therefore, the GRU/CRNN has a 3.63 percentage-point higher test accuracy.</a:t>
+            </a:r>
+          </a:p>
+          <a:p>
+            <a:r>
+              <a:rPr lang="en-US" dirty="0"/>
+              <a:t>The Time-Distributed variant achieved 56.25%. The difference between the two </a:t>
+            </a:r>
+            <a:r>
+              <a:rPr lang="en-US" dirty="0" err="1"/>
+              <a:t>SongNet</a:t>
+            </a:r>
+            <a:r>
+              <a:rPr lang="en-US" dirty="0"/>
+              <a:t> variants suggests that explicitly modelling temporal dependencies with the GRU may be useful.</a:t>
+            </a:r>
           </a:p>
         </p:txBody>
       </p:sp>
@@ -1587,7 +1613,7 @@
           </a:prstGeom>
           <a:extLst>
             <a:ext uri="{C572A759-6A51-4108-AA02-DFA0A04FC94B}">
-              <ma14:wrappingTextBoxFlag xmlns="" xmlns:ma14="http://schemas.microsoft.com/office/mac/drawingml/2011/main" val="0"/>
+              <ma14:wrappingTextBoxFlag xmlns:ma14="http://schemas.microsoft.com/office/mac/drawingml/2011/main" xmlns="" val="0"/>
             </a:ext>
           </a:extLst>
         </p:spPr>
@@ -1665,7 +1691,7 @@
           </a:prstGeom>
           <a:extLst>
             <a:ext uri="{C572A759-6A51-4108-AA02-DFA0A04FC94B}">
-              <ma14:wrappingTextBoxFlag xmlns="" xmlns:ma14="http://schemas.microsoft.com/office/mac/drawingml/2011/main" val="0"/>
+              <ma14:wrappingTextBoxFlag xmlns:ma14="http://schemas.microsoft.com/office/mac/drawingml/2011/main" xmlns="" val="0"/>
             </a:ext>
           </a:extLst>
         </p:spPr>
@@ -2373,27 +2399,6 @@
             </a:r>
             <a:endParaRPr lang="en-US" sz="1900" dirty="0"/>
           </a:p>
-          <a:p>
-            <a:pPr marL="342900" indent="-342900">
-              <a:spcAft>
-                <a:spcPts val="800"/>
-              </a:spcAft>
-              <a:buSzPct val="100000"/>
-              <a:buChar char="•"/>
-            </a:pPr>
-            <a:r>
-              <a:rPr lang="en-US" sz="1900" dirty="0">
-                <a:solidFill>
-                  <a:srgbClr val="222222"/>
-                </a:solidFill>
-                <a:latin typeface="Calibri" pitchFamily="34" charset="0"/>
-                <a:ea typeface="Calibri" pitchFamily="34" charset="-122"/>
-                <a:cs typeface="Calibri" pitchFamily="34" charset="-120"/>
-              </a:rPr>
-              <a:t>Not claimed: streaming latency was not benchmarked; per-step outputs are a foundation for real-time tracking</a:t>
-            </a:r>
-            <a:endParaRPr lang="en-US" sz="1900" dirty="0"/>
-          </a:p>
         </p:txBody>
       </p:sp>
       <p:sp>
@@ -2416,7 +2421,7 @@
           </a:prstGeom>
           <a:extLst>
             <a:ext uri="{C572A759-6A51-4108-AA02-DFA0A04FC94B}">
-              <ma14:wrappingTextBoxFlag xmlns="" xmlns:ma14="http://schemas.microsoft.com/office/mac/drawingml/2011/main" val="0"/>
+              <ma14:wrappingTextBoxFlag xmlns:ma14="http://schemas.microsoft.com/office/mac/drawingml/2011/main" xmlns="" val="0"/>
             </a:ext>
           </a:extLst>
         </p:spPr>
@@ -3116,9 +3121,8 @@
                 <a:ea typeface="Calibri" pitchFamily="34" charset="-122"/>
                 <a:cs typeface="Calibri" pitchFamily="34" charset="-120"/>
               </a:rPr>
-              <a:t>Stratified 70/20/10 split; test = 100 tracks per genre</a:t>
-            </a:r>
-            <a:endParaRPr lang="en-US" sz="1600" dirty="0"/>
+              <a:t>Stratified 70/20/10 split; </a:t>
+            </a:r>
           </a:p>
           <a:p>
             <a:pPr marL="342900" indent="-342900">
@@ -3129,7 +3133,7 @@
               <a:buChar char="•"/>
             </a:pPr>
             <a:r>
-              <a:rPr lang="en-US" sz="1600" dirty="0">
+              <a:rPr lang="en-US" sz="1600" dirty="0" err="1">
                 <a:solidFill>
                   <a:srgbClr val="222222"/>
                 </a:solidFill>
@@ -3137,7 +3141,18 @@
                 <a:ea typeface="Calibri" pitchFamily="34" charset="-122"/>
                 <a:cs typeface="Calibri" pitchFamily="34" charset="-120"/>
               </a:rPr>
-              <a:t>Normalisation statistics from the training split only</a:t>
+              <a:t>Normalisation</a:t>
+            </a:r>
+            <a:r>
+              <a:rPr lang="en-US" sz="1600" dirty="0">
+                <a:solidFill>
+                  <a:srgbClr val="222222"/>
+                </a:solidFill>
+                <a:latin typeface="Calibri" pitchFamily="34" charset="0"/>
+                <a:ea typeface="Calibri" pitchFamily="34" charset="-122"/>
+                <a:cs typeface="Calibri" pitchFamily="34" charset="-120"/>
+              </a:rPr>
+              <a:t> statistics from the training split only</a:t>
             </a:r>
             <a:endParaRPr lang="en-US" sz="1600" dirty="0"/>
           </a:p>
@@ -3163,7 +3178,7 @@
           </a:prstGeom>
           <a:extLst>
             <a:ext uri="{C572A759-6A51-4108-AA02-DFA0A04FC94B}">
-              <ma14:wrappingTextBoxFlag xmlns="" xmlns:ma14="http://schemas.microsoft.com/office/mac/drawingml/2011/main" val="0"/>
+              <ma14:wrappingTextBoxFlag xmlns:ma14="http://schemas.microsoft.com/office/mac/drawingml/2011/main" xmlns="" val="0"/>
             </a:ext>
           </a:extLst>
         </p:spPr>
@@ -4067,7 +4082,7 @@
           </a:prstGeom>
           <a:extLst>
             <a:ext uri="{C572A759-6A51-4108-AA02-DFA0A04FC94B}">
-              <ma14:wrappingTextBoxFlag xmlns="" xmlns:ma14="http://schemas.microsoft.com/office/mac/drawingml/2011/main" val="0"/>
+              <ma14:wrappingTextBoxFlag xmlns:ma14="http://schemas.microsoft.com/office/mac/drawingml/2011/main" xmlns="" val="0"/>
             </a:ext>
           </a:extLst>
         </p:spPr>
@@ -4440,7 +4455,7 @@
           </a:prstGeom>
           <a:extLst>
             <a:ext uri="{C572A759-6A51-4108-AA02-DFA0A04FC94B}">
-              <ma14:wrappingTextBoxFlag xmlns="" xmlns:ma14="http://schemas.microsoft.com/office/mac/drawingml/2011/main" val="0"/>
+              <ma14:wrappingTextBoxFlag xmlns:ma14="http://schemas.microsoft.com/office/mac/drawingml/2011/main" xmlns="" val="0"/>
             </a:ext>
           </a:extLst>
         </p:spPr>
@@ -4794,7 +4809,7 @@
           </a:prstGeom>
           <a:extLst>
             <a:ext uri="{C572A759-6A51-4108-AA02-DFA0A04FC94B}">
-              <ma14:wrappingTextBoxFlag xmlns="" xmlns:ma14="http://schemas.microsoft.com/office/mac/drawingml/2011/main" val="0"/>
+              <ma14:wrappingTextBoxFlag xmlns:ma14="http://schemas.microsoft.com/office/mac/drawingml/2011/main" xmlns="" val="0"/>
             </a:ext>
           </a:extLst>
         </p:spPr>
@@ -7628,7 +7643,7 @@
           </a:prstGeom>
           <a:extLst>
             <a:ext uri="{C572A759-6A51-4108-AA02-DFA0A04FC94B}">
-              <ma14:wrappingTextBoxFlag xmlns="" xmlns:ma14="http://schemas.microsoft.com/office/mac/drawingml/2011/main" val="0"/>
+              <ma14:wrappingTextBoxFlag xmlns:ma14="http://schemas.microsoft.com/office/mac/drawingml/2011/main" xmlns="" val="0"/>
             </a:ext>
           </a:extLst>
         </p:spPr>
@@ -8041,7 +8056,7 @@
           </a:prstGeom>
           <a:extLst>
             <a:ext uri="{C572A759-6A51-4108-AA02-DFA0A04FC94B}">
-              <ma14:wrappingTextBoxFlag xmlns="" xmlns:ma14="http://schemas.microsoft.com/office/mac/drawingml/2011/main" val="0"/>
+              <ma14:wrappingTextBoxFlag xmlns:ma14="http://schemas.microsoft.com/office/mac/drawingml/2011/main" xmlns="" val="0"/>
             </a:ext>
           </a:extLst>
         </p:spPr>
@@ -8155,7 +8170,7 @@
                 <a:ea typeface="Calibri" pitchFamily="34" charset="-122"/>
                 <a:cs typeface="Calibri" pitchFamily="34" charset="-120"/>
               </a:rPr>
-              <a:t>Conclusions &amp; Future Work</a:t>
+              <a:t>Conclusions</a:t>
             </a:r>
             <a:endParaRPr lang="en-US" sz="2600" dirty="0"/>
           </a:p>
@@ -8269,45 +8284,6 @@
       </p:sp>
       <p:sp>
         <p:nvSpPr>
-          <p:cNvPr id="5" name="Text 3"/>
-          <p:cNvSpPr txBox="1"/>
-          <p:nvPr/>
-        </p:nvSpPr>
-        <p:spPr>
-          <a:xfrm>
-            <a:off x="548640" y="4206240"/>
-            <a:ext cx="8046720" cy="457200"/>
-          </a:xfrm>
-          <a:prstGeom prst="rect">
-            <a:avLst/>
-          </a:prstGeom>
-          <a:noFill/>
-          <a:ln/>
-        </p:spPr>
-        <p:txBody>
-          <a:bodyPr wrap="square" lIns="0" tIns="0" rIns="0" bIns="0" rtlCol="0" anchor="ctr"/>
-          <a:lstStyle/>
-          <a:p>
-            <a:pPr marL="0" indent="0">
-              <a:buNone/>
-            </a:pPr>
-            <a:r>
-              <a:rPr lang="en-US" sz="2400" b="1" dirty="0">
-                <a:solidFill>
-                  <a:srgbClr val="2E86C1"/>
-                </a:solidFill>
-                <a:latin typeface="Calibri" pitchFamily="34" charset="0"/>
-                <a:ea typeface="Calibri" pitchFamily="34" charset="-122"/>
-                <a:cs typeface="Calibri" pitchFamily="34" charset="-120"/>
-              </a:rPr>
-              <a:t>Questions?</a:t>
-            </a:r>
-            <a:endParaRPr lang="en-US" sz="2400" dirty="0"/>
-          </a:p>
-        </p:txBody>
-      </p:sp>
-      <p:sp>
-        <p:nvSpPr>
           <p:cNvPr id="25" name="Slide Number Placeholder 0"/>
           <p:cNvSpPr>
             <a:spLocks noGrp="1"/>
@@ -8326,7 +8302,7 @@
           </a:prstGeom>
           <a:extLst>
             <a:ext uri="{C572A759-6A51-4108-AA02-DFA0A04FC94B}">
-              <ma14:wrappingTextBoxFlag xmlns="" xmlns:ma14="http://schemas.microsoft.com/office/mac/drawingml/2011/main" val="0"/>
+              <ma14:wrappingTextBoxFlag xmlns:ma14="http://schemas.microsoft.com/office/mac/drawingml/2011/main" xmlns="" val="0"/>
             </a:ext>
           </a:extLst>
         </p:spPr>

</xml_diff>